<commit_message>
feat: Implement pagination policy and slide registry for enhanced slide generation
- Added pagination policy management with schema versioning and validation.
- Introduced a new slide registry to manage slide types, builders, and pagination policies.
- Integrated pagination policy checks into the render context and deck rendering processes.
- Updated template package loading to include pagination policy data.
- Created a JSON schema for pagination policies with various strategies and options.
- Enhanced documentation for slide contracts, quality assurance, and layout policies to reflect new pagination behaviors.
- Added new pagination-related fields and checks in the quality assurance process.
</commit_message>
<xml_diff>
--- a/kpmg-utils/kpmg-slidegen/outputs/qa-golden-fixture/skill-smoke/deck.pptx
+++ b/kpmg-utils/kpmg-slidegen/outputs/qa-golden-fixture/skill-smoke/deck.pptx
@@ -386,7 +386,7 @@
           <a:lstStyle/>
           <a:p>
             <a:pPr>
-              <a:defRPr sz="700" b="0" i="0" u="none" strike="noStrike">
+              <a:defRPr sz="800" b="0" i="0" u="none" strike="noStrike">
                 <a:solidFill>
                   <a:srgbClr val="000000"/>
                 </a:solidFill>
@@ -427,7 +427,7 @@
           <a:lstStyle/>
           <a:p>
             <a:pPr>
-              <a:defRPr sz="700" b="0" i="0" u="none" strike="noStrike">
+              <a:defRPr sz="800" b="0" i="0" u="none" strike="noStrike">
                 <a:solidFill>
                   <a:srgbClr val="000000"/>
                 </a:solidFill>
@@ -746,7 +746,7 @@
           <a:lstStyle/>
           <a:p>
             <a:pPr>
-              <a:defRPr sz="700" b="0" i="0" u="none" strike="noStrike">
+              <a:defRPr sz="800" b="0" i="0" u="none" strike="noStrike">
                 <a:solidFill>
                   <a:srgbClr val="000000"/>
                 </a:solidFill>
@@ -787,7 +787,7 @@
           <a:lstStyle/>
           <a:p>
             <a:pPr>
-              <a:defRPr sz="700" b="0" i="0" u="none" strike="noStrike">
+              <a:defRPr sz="800" b="0" i="0" u="none" strike="noStrike">
                 <a:solidFill>
                   <a:srgbClr val="000000"/>
                 </a:solidFill>
@@ -1018,7 +1018,7 @@
           <a:lstStyle/>
           <a:p>
             <a:pPr>
-              <a:defRPr sz="700" b="0" i="0" u="none" strike="noStrike">
+              <a:defRPr sz="800" b="0" i="0" u="none" strike="noStrike">
                 <a:solidFill>
                   <a:srgbClr val="000000"/>
                 </a:solidFill>
@@ -1059,7 +1059,7 @@
           <a:lstStyle/>
           <a:p>
             <a:pPr>
-              <a:defRPr sz="700" b="0" i="0" u="none" strike="noStrike">
+              <a:defRPr sz="800" b="0" i="0" u="none" strike="noStrike">
                 <a:solidFill>
                   <a:srgbClr val="000000"/>
                 </a:solidFill>
@@ -1398,7 +1398,7 @@
           <a:lstStyle/>
           <a:p>
             <a:pPr>
-              <a:defRPr sz="700" b="0" i="0" u="none" strike="noStrike">
+              <a:defRPr sz="800" b="0" i="0" u="none" strike="noStrike">
                 <a:solidFill>
                   <a:srgbClr val="000000"/>
                 </a:solidFill>
@@ -1439,7 +1439,7 @@
           <a:lstStyle/>
           <a:p>
             <a:pPr>
-              <a:defRPr sz="700" b="0" i="0" u="none" strike="noStrike">
+              <a:defRPr sz="800" b="0" i="0" u="none" strike="noStrike">
                 <a:solidFill>
                   <a:srgbClr val="000000"/>
                 </a:solidFill>
@@ -2016,7 +2016,7 @@
           <a:lstStyle/>
           <a:p>
             <a:pPr>
-              <a:defRPr sz="700" b="0" i="0" u="none" strike="noStrike">
+              <a:defRPr sz="800" b="0" i="0" u="none" strike="noStrike">
                 <a:solidFill>
                   <a:srgbClr val="000000"/>
                 </a:solidFill>
@@ -2057,7 +2057,7 @@
           <a:lstStyle/>
           <a:p>
             <a:pPr>
-              <a:defRPr sz="700" b="0" i="0" u="none" strike="noStrike">
+              <a:defRPr sz="800" b="0" i="0" u="none" strike="noStrike">
                 <a:solidFill>
                   <a:srgbClr val="000000"/>
                 </a:solidFill>
@@ -2376,7 +2376,7 @@
           <a:lstStyle/>
           <a:p>
             <a:pPr>
-              <a:defRPr sz="700" b="0" i="0" u="none" strike="noStrike">
+              <a:defRPr sz="800" b="0" i="0" u="none" strike="noStrike">
                 <a:solidFill>
                   <a:srgbClr val="000000"/>
                 </a:solidFill>
@@ -2417,7 +2417,7 @@
           <a:lstStyle/>
           <a:p>
             <a:pPr>
-              <a:defRPr sz="700" b="0" i="0" u="none" strike="noStrike">
+              <a:defRPr sz="800" b="0" i="0" u="none" strike="noStrike">
                 <a:solidFill>
                   <a:srgbClr val="000000"/>
                 </a:solidFill>
@@ -2756,7 +2756,7 @@
           <a:lstStyle/>
           <a:p>
             <a:pPr>
-              <a:defRPr sz="700" b="0" i="0" u="none" strike="noStrike">
+              <a:defRPr sz="800" b="0" i="0" u="none" strike="noStrike">
                 <a:solidFill>
                   <a:srgbClr val="000000"/>
                 </a:solidFill>
@@ -2797,7 +2797,7 @@
           <a:lstStyle/>
           <a:p>
             <a:pPr>
-              <a:defRPr sz="700" b="0" i="0" u="none" strike="noStrike">
+              <a:defRPr sz="800" b="0" i="0" u="none" strike="noStrike">
                 <a:solidFill>
                   <a:srgbClr val="000000"/>
                 </a:solidFill>
@@ -5021,7 +5021,7 @@
       </p:grpSpPr>
       <p:pic>
         <p:nvPicPr>
-          <p:cNvPr id="2" name="Image 0" descr="/Users/rishi/Code/ai-tools/chatgpt/kpmg-slidegen/skills/kpmg-slides/assets/slidegen/templates/kpmg-diligence/assets/kpmg-logo.svg">    </p:cNvPr>
+          <p:cNvPr id="2" name="Image 0" descr="/Users/rishi/Code/ai-tools/kpmg-utils/kpmg-slidegen/skills/kpmg-slides/assets/slidegen/templates/kpmg-diligence/assets/kpmg-logo.svg">    </p:cNvPr>
           <p:cNvPicPr>
             <a:picLocks noChangeAspect="1"/>
           </p:cNvPicPr>
@@ -5223,7 +5223,7 @@
       </p:grpSpPr>
       <p:pic>
         <p:nvPicPr>
-          <p:cNvPr id="2" name="Image 0" descr="/Users/rishi/Code/ai-tools/chatgpt/kpmg-slidegen/skills/kpmg-slides/assets/slidegen/templates/kpmg-diligence/assets/gradient_accent_chip_300dpi.png">    </p:cNvPr>
+          <p:cNvPr id="2" name="Image 0" descr="/Users/rishi/Code/ai-tools/kpmg-utils/kpmg-slidegen/skills/kpmg-slides/assets/slidegen/templates/kpmg-diligence/assets/gradient_accent_chip_300dpi.png">    </p:cNvPr>
           <p:cNvPicPr>
             <a:picLocks noChangeAspect="1"/>
           </p:cNvPicPr>
@@ -5247,7 +5247,7 @@
       </p:pic>
       <p:pic>
         <p:nvPicPr>
-          <p:cNvPr id="3" name="Image 1" descr="/Users/rishi/Code/ai-tools/chatgpt/kpmg-slidegen/skills/kpmg-slides/assets/slidegen/templates/kpmg-diligence/assets/kpmg-logo.svg">    </p:cNvPr>
+          <p:cNvPr id="3" name="Image 1" descr="/Users/rishi/Code/ai-tools/kpmg-utils/kpmg-slidegen/skills/kpmg-slides/assets/slidegen/templates/kpmg-diligence/assets/kpmg-logo.svg">    </p:cNvPr>
           <p:cNvPicPr>
             <a:picLocks noChangeAspect="1"/>
           </p:cNvPicPr>
@@ -5481,7 +5481,7 @@
       </p:grpSpPr>
       <p:pic>
         <p:nvPicPr>
-          <p:cNvPr id="2" name="Image 0" descr="/Users/rishi/Code/ai-tools/chatgpt/kpmg-slidegen/skills/kpmg-slides/assets/slidegen/templates/kpmg-diligence/assets/gradient_divider_window_300dpi.png">    </p:cNvPr>
+          <p:cNvPr id="2" name="Image 0" descr="/Users/rishi/Code/ai-tools/kpmg-utils/kpmg-slidegen/skills/kpmg-slides/assets/slidegen/templates/kpmg-diligence/assets/gradient_divider_window_300dpi.png">    </p:cNvPr>
           <p:cNvPicPr>
             <a:picLocks noChangeAspect="1"/>
           </p:cNvPicPr>
@@ -5537,7 +5537,7 @@
       </p:grpSpPr>
       <p:pic>
         <p:nvPicPr>
-          <p:cNvPr id="2" name="Image 0" descr="/Users/rishi/Code/ai-tools/chatgpt/kpmg-slidegen/skills/kpmg-slides/assets/slidegen/templates/kpmg-diligence/assets/gradient_divider_window_300dpi.png">    </p:cNvPr>
+          <p:cNvPr id="2" name="Image 0" descr="/Users/rishi/Code/ai-tools/kpmg-utils/kpmg-slidegen/skills/kpmg-slides/assets/slidegen/templates/kpmg-diligence/assets/gradient_divider_window_300dpi.png">    </p:cNvPr>
           <p:cNvPicPr>
             <a:picLocks noChangeAspect="1"/>
           </p:cNvPicPr>
@@ -5625,7 +5625,7 @@
       </p:grpSpPr>
       <p:pic>
         <p:nvPicPr>
-          <p:cNvPr id="2" name="Image 0" descr="/Users/rishi/Code/ai-tools/chatgpt/kpmg-slidegen/skills/kpmg-slides/assets/slidegen/templates/kpmg-diligence/assets/gradient_back_cover_300dpi.png">    </p:cNvPr>
+          <p:cNvPr id="2" name="Image 0" descr="/Users/rishi/Code/ai-tools/kpmg-utils/kpmg-slidegen/skills/kpmg-slides/assets/slidegen/templates/kpmg-diligence/assets/gradient_back_cover_300dpi.png">    </p:cNvPr>
           <p:cNvPicPr>
             <a:picLocks noChangeAspect="1"/>
           </p:cNvPicPr>
@@ -6005,85 +6005,85 @@
               <a:buNone/>
             </a:pPr>
             <a:r>
-              <a:rPr lang="en-US" sz="4000" b="1" dirty="0">
+              <a:rPr lang="en-US" sz="4700" b="1" dirty="0">
                 <a:solidFill>
                   <a:srgbClr val="FFFFFF"/>
                 </a:solidFill>
-                <a:latin typeface="KPMG-Bold" pitchFamily="34" charset="0"/>
-                <a:ea typeface="KPMG-Bold" pitchFamily="34" charset="-122"/>
-                <a:cs typeface="KPMG-Bold" pitchFamily="34" charset="-120"/>
+                <a:latin typeface="Arial" pitchFamily="34" charset="0"/>
+                <a:ea typeface="Arial" pitchFamily="34" charset="-122"/>
+                <a:cs typeface="Arial" pitchFamily="34" charset="-120"/>
               </a:rPr>
               <a:t>PartyThrow</a:t>
             </a:r>
-            <a:endParaRPr lang="en-US" sz="4000" dirty="0"/>
+            <a:endParaRPr lang="en-US" sz="4700" dirty="0"/>
           </a:p>
           <a:p>
             <a:pPr algn="l" indent="0" marL="0">
               <a:buNone/>
             </a:pPr>
             <a:r>
-              <a:rPr lang="en-US" sz="4000" b="1" dirty="0">
+              <a:rPr lang="en-US" sz="4700" b="1" dirty="0">
                 <a:solidFill>
                   <a:srgbClr val="FFFFFF"/>
                 </a:solidFill>
-                <a:latin typeface="KPMG-Bold" pitchFamily="34" charset="0"/>
-                <a:ea typeface="KPMG-Bold" pitchFamily="34" charset="-122"/>
-                <a:cs typeface="KPMG-Bold" pitchFamily="34" charset="-120"/>
+                <a:latin typeface="Arial" pitchFamily="34" charset="0"/>
+                <a:ea typeface="Arial" pitchFamily="34" charset="-122"/>
+                <a:cs typeface="Arial" pitchFamily="34" charset="-120"/>
               </a:rPr>
               <a:t>Tech:</a:t>
             </a:r>
-            <a:endParaRPr lang="en-US" sz="4000" dirty="0"/>
+            <a:endParaRPr lang="en-US" sz="4700" dirty="0"/>
           </a:p>
           <a:p>
             <a:pPr algn="l" indent="0" marL="0">
               <a:buNone/>
             </a:pPr>
             <a:r>
-              <a:rPr lang="en-US" sz="4000" b="1" dirty="0">
+              <a:rPr lang="en-US" sz="4700" b="1" dirty="0">
                 <a:solidFill>
                   <a:srgbClr val="FFFFFF"/>
                 </a:solidFill>
-                <a:latin typeface="KPMG-Bold" pitchFamily="34" charset="0"/>
-                <a:ea typeface="KPMG-Bold" pitchFamily="34" charset="-122"/>
-                <a:cs typeface="KPMG-Bold" pitchFamily="34" charset="-120"/>
+                <a:latin typeface="Arial" pitchFamily="34" charset="0"/>
+                <a:ea typeface="Arial" pitchFamily="34" charset="-122"/>
+                <a:cs typeface="Arial" pitchFamily="34" charset="-120"/>
               </a:rPr>
               <a:t>Mid-Market</a:t>
             </a:r>
-            <a:endParaRPr lang="en-US" sz="4000" dirty="0"/>
+            <a:endParaRPr lang="en-US" sz="4700" dirty="0"/>
           </a:p>
           <a:p>
             <a:pPr algn="l" indent="0" marL="0">
               <a:buNone/>
             </a:pPr>
             <a:r>
-              <a:rPr lang="en-US" sz="4000" b="1" dirty="0">
+              <a:rPr lang="en-US" sz="4700" b="1" dirty="0">
                 <a:solidFill>
                   <a:srgbClr val="FFFFFF"/>
                 </a:solidFill>
-                <a:latin typeface="KPMG-Bold" pitchFamily="34" charset="0"/>
-                <a:ea typeface="KPMG-Bold" pitchFamily="34" charset="-122"/>
-                <a:cs typeface="KPMG-Bold" pitchFamily="34" charset="-120"/>
+                <a:latin typeface="Arial" pitchFamily="34" charset="0"/>
+                <a:ea typeface="Arial" pitchFamily="34" charset="-122"/>
+                <a:cs typeface="Arial" pitchFamily="34" charset="-120"/>
               </a:rPr>
               <a:t>SaaS</a:t>
             </a:r>
-            <a:endParaRPr lang="en-US" sz="4000" dirty="0"/>
+            <a:endParaRPr lang="en-US" sz="4700" dirty="0"/>
           </a:p>
           <a:p>
             <a:pPr algn="l" indent="0" marL="0">
               <a:buNone/>
             </a:pPr>
             <a:r>
-              <a:rPr lang="en-US" sz="4000" b="1" dirty="0">
+              <a:rPr lang="en-US" sz="4700" b="1" dirty="0">
                 <a:solidFill>
                   <a:srgbClr val="FFFFFF"/>
                 </a:solidFill>
-                <a:latin typeface="KPMG-Bold" pitchFamily="34" charset="0"/>
-                <a:ea typeface="KPMG-Bold" pitchFamily="34" charset="-122"/>
-                <a:cs typeface="KPMG-Bold" pitchFamily="34" charset="-120"/>
+                <a:latin typeface="Arial" pitchFamily="34" charset="0"/>
+                <a:ea typeface="Arial" pitchFamily="34" charset="-122"/>
+                <a:cs typeface="Arial" pitchFamily="34" charset="-120"/>
               </a:rPr>
               <a:t>Diligence</a:t>
             </a:r>
-            <a:endParaRPr lang="en-US" sz="4000" dirty="0"/>
+            <a:endParaRPr lang="en-US" sz="4700" dirty="0"/>
           </a:p>
         </p:txBody>
       </p:sp>
@@ -6182,8 +6182,8 @@
         </p:nvSpPr>
         <p:spPr>
           <a:xfrm>
-            <a:off x="998433" y="431780"/>
-            <a:ext cx="10204338" cy="533370"/>
+            <a:off x="998400" y="431800"/>
+            <a:ext cx="10195200" cy="533400"/>
           </a:xfrm>
           <a:prstGeom prst="rect">
             <a:avLst/>
@@ -6199,17 +6199,17 @@
               <a:buNone/>
             </a:pPr>
             <a:r>
-              <a:rPr lang="en-US" sz="3200" b="1" dirty="0">
+              <a:rPr lang="en-US" sz="2400" b="1" dirty="0">
                 <a:solidFill>
                   <a:srgbClr val="00338D"/>
                 </a:solidFill>
-                <a:latin typeface="KPMG-Bold" pitchFamily="34" charset="0"/>
-                <a:ea typeface="KPMG-Bold" pitchFamily="34" charset="-122"/>
-                <a:cs typeface="KPMG-Bold" pitchFamily="34" charset="-120"/>
+                <a:latin typeface="Arial" pitchFamily="34" charset="0"/>
+                <a:ea typeface="Arial" pitchFamily="34" charset="-122"/>
+                <a:cs typeface="Arial" pitchFamily="34" charset="-120"/>
               </a:rPr>
               <a:t>ARR reached $135.2M with sustained momentum</a:t>
             </a:r>
-            <a:endParaRPr lang="en-US" sz="3200" dirty="0"/>
+            <a:endParaRPr lang="en-US" sz="2400" dirty="0"/>
           </a:p>
         </p:txBody>
       </p:sp>
@@ -6221,8 +6221,8 @@
         </p:nvSpPr>
         <p:spPr>
           <a:xfrm>
-            <a:off x="998433" y="1179485"/>
-            <a:ext cx="10204338" cy="482437"/>
+            <a:off x="995361" y="1179513"/>
+            <a:ext cx="10192299" cy="482400"/>
           </a:xfrm>
           <a:prstGeom prst="rect">
             <a:avLst/>
@@ -6260,8 +6260,8 @@
         </p:nvSpPr>
         <p:spPr>
           <a:xfrm>
-            <a:off x="998433" y="1716786"/>
-            <a:ext cx="5120640" cy="4459072"/>
+            <a:off x="995361" y="3859200"/>
+            <a:ext cx="5036400" cy="2016000"/>
           </a:xfrm>
           <a:prstGeom prst="rect">
             <a:avLst/>
@@ -6394,8 +6394,8 @@
           <p:nvPr/>
         </p:nvGraphicFramePr>
         <p:xfrm>
-          <a:off x="6400800" y="1716786"/>
-          <a:ext cx="4800600" cy="4184752"/>
+          <a:off x="6159600" y="3859199"/>
+          <a:ext cx="5036400" cy="2016000"/>
         </p:xfrm>
         <a:graphic xmlns:a="http://schemas.openxmlformats.org/drawingml/2006/main">
           <a:graphicData uri="http://schemas.openxmlformats.org/drawingml/2006/chart">
@@ -6411,8 +6411,8 @@
         </p:nvSpPr>
         <p:spPr>
           <a:xfrm>
-            <a:off x="6400800" y="5947258"/>
-            <a:ext cx="4800600" cy="182880"/>
+            <a:off x="6159600" y="5920919"/>
+            <a:ext cx="5036400" cy="182880"/>
           </a:xfrm>
           <a:prstGeom prst="rect">
             <a:avLst/>
@@ -6514,8 +6514,8 @@
         </p:nvSpPr>
         <p:spPr>
           <a:xfrm>
-            <a:off x="998433" y="431780"/>
-            <a:ext cx="10204338" cy="533370"/>
+            <a:off x="998400" y="431800"/>
+            <a:ext cx="10195200" cy="533400"/>
           </a:xfrm>
           <a:prstGeom prst="rect">
             <a:avLst/>
@@ -6531,17 +6531,17 @@
               <a:buNone/>
             </a:pPr>
             <a:r>
-              <a:rPr lang="en-US" sz="3200" b="1" dirty="0">
+              <a:rPr lang="en-US" sz="2400" b="1" dirty="0">
                 <a:solidFill>
                   <a:srgbClr val="00338D"/>
                 </a:solidFill>
-                <a:latin typeface="KPMG-Bold" pitchFamily="34" charset="0"/>
-                <a:ea typeface="KPMG-Bold" pitchFamily="34" charset="-122"/>
-                <a:cs typeface="KPMG-Bold" pitchFamily="34" charset="-120"/>
+                <a:latin typeface="Arial" pitchFamily="34" charset="0"/>
+                <a:ea typeface="Arial" pitchFamily="34" charset="-122"/>
+                <a:cs typeface="Arial" pitchFamily="34" charset="-120"/>
               </a:rPr>
               <a:t>Customer base tripled as ARPU normalized</a:t>
             </a:r>
-            <a:endParaRPr lang="en-US" sz="3200" dirty="0"/>
+            <a:endParaRPr lang="en-US" sz="2400" dirty="0"/>
           </a:p>
         </p:txBody>
       </p:sp>
@@ -6553,8 +6553,8 @@
         </p:nvSpPr>
         <p:spPr>
           <a:xfrm>
-            <a:off x="998433" y="1179485"/>
-            <a:ext cx="10204338" cy="482437"/>
+            <a:off x="995361" y="1179513"/>
+            <a:ext cx="10192299" cy="482400"/>
           </a:xfrm>
           <a:prstGeom prst="rect">
             <a:avLst/>
@@ -6592,8 +6592,8 @@
         </p:nvSpPr>
         <p:spPr>
           <a:xfrm>
-            <a:off x="998433" y="1716786"/>
-            <a:ext cx="5120640" cy="4459072"/>
+            <a:off x="995361" y="3859200"/>
+            <a:ext cx="5036400" cy="2016000"/>
           </a:xfrm>
           <a:prstGeom prst="rect">
             <a:avLst/>
@@ -6726,8 +6726,8 @@
           <p:nvPr/>
         </p:nvGraphicFramePr>
         <p:xfrm>
-          <a:off x="6400800" y="1716786"/>
-          <a:ext cx="4800600" cy="4184752"/>
+          <a:off x="6159600" y="3859199"/>
+          <a:ext cx="5036400" cy="2016000"/>
         </p:xfrm>
         <a:graphic xmlns:a="http://schemas.openxmlformats.org/drawingml/2006/main">
           <a:graphicData uri="http://schemas.openxmlformats.org/drawingml/2006/chart">
@@ -6743,8 +6743,8 @@
         </p:nvSpPr>
         <p:spPr>
           <a:xfrm>
-            <a:off x="6400800" y="5947258"/>
-            <a:ext cx="4800600" cy="182880"/>
+            <a:off x="6159600" y="5920919"/>
+            <a:ext cx="5036400" cy="182880"/>
           </a:xfrm>
           <a:prstGeom prst="rect">
             <a:avLst/>
@@ -6846,8 +6846,8 @@
         </p:nvSpPr>
         <p:spPr>
           <a:xfrm>
-            <a:off x="998433" y="431780"/>
-            <a:ext cx="10204338" cy="533370"/>
+            <a:off x="998400" y="431800"/>
+            <a:ext cx="10195200" cy="533400"/>
           </a:xfrm>
           <a:prstGeom prst="rect">
             <a:avLst/>
@@ -6863,17 +6863,17 @@
               <a:buNone/>
             </a:pPr>
             <a:r>
-              <a:rPr lang="en-US" sz="3200" b="1" dirty="0">
+              <a:rPr lang="en-US" sz="2400" b="1" dirty="0">
                 <a:solidFill>
                   <a:srgbClr val="00338D"/>
                 </a:solidFill>
-                <a:latin typeface="KPMG-Bold" pitchFamily="34" charset="0"/>
-                <a:ea typeface="KPMG-Bold" pitchFamily="34" charset="-122"/>
-                <a:cs typeface="KPMG-Bold" pitchFamily="34" charset="-120"/>
+                <a:latin typeface="Arial" pitchFamily="34" charset="0"/>
+                <a:ea typeface="Arial" pitchFamily="34" charset="-122"/>
+                <a:cs typeface="Arial" pitchFamily="34" charset="-120"/>
               </a:rPr>
               <a:t>Net new MRR stayed positive despite churn</a:t>
             </a:r>
-            <a:endParaRPr lang="en-US" sz="3200" dirty="0"/>
+            <a:endParaRPr lang="en-US" sz="2400" dirty="0"/>
           </a:p>
         </p:txBody>
       </p:sp>
@@ -6885,8 +6885,8 @@
         </p:nvSpPr>
         <p:spPr>
           <a:xfrm>
-            <a:off x="998433" y="1179485"/>
-            <a:ext cx="10204338" cy="482437"/>
+            <a:off x="995361" y="1179513"/>
+            <a:ext cx="10192299" cy="482400"/>
           </a:xfrm>
           <a:prstGeom prst="rect">
             <a:avLst/>
@@ -6924,8 +6924,8 @@
         </p:nvSpPr>
         <p:spPr>
           <a:xfrm>
-            <a:off x="998433" y="1716786"/>
-            <a:ext cx="5120640" cy="4459072"/>
+            <a:off x="995361" y="3859200"/>
+            <a:ext cx="5036400" cy="2016000"/>
           </a:xfrm>
           <a:prstGeom prst="rect">
             <a:avLst/>
@@ -7058,8 +7058,8 @@
           <p:nvPr/>
         </p:nvGraphicFramePr>
         <p:xfrm>
-          <a:off x="6400800" y="1716786"/>
-          <a:ext cx="4800600" cy="4184752"/>
+          <a:off x="6159600" y="3859199"/>
+          <a:ext cx="5036400" cy="2016000"/>
         </p:xfrm>
         <a:graphic xmlns:a="http://schemas.openxmlformats.org/drawingml/2006/main">
           <a:graphicData uri="http://schemas.openxmlformats.org/drawingml/2006/chart">
@@ -7075,8 +7075,8 @@
         </p:nvSpPr>
         <p:spPr>
           <a:xfrm>
-            <a:off x="6400800" y="5947258"/>
-            <a:ext cx="4800600" cy="182880"/>
+            <a:off x="6159600" y="5920919"/>
+            <a:ext cx="5036400" cy="182880"/>
           </a:xfrm>
           <a:prstGeom prst="rect">
             <a:avLst/>
@@ -7199,9 +7199,9 @@
                 <a:solidFill>
                   <a:srgbClr val="FFFFFF"/>
                 </a:solidFill>
-                <a:latin typeface="KPMG-Bold" pitchFamily="34" charset="0"/>
-                <a:ea typeface="KPMG-Bold" pitchFamily="34" charset="-122"/>
-                <a:cs typeface="KPMG-Bold" pitchFamily="34" charset="-120"/>
+                <a:latin typeface="Arial" pitchFamily="34" charset="0"/>
+                <a:ea typeface="Arial" pitchFamily="34" charset="-122"/>
+                <a:cs typeface="Arial" pitchFamily="34" charset="-120"/>
               </a:rPr>
               <a:t>04</a:t>
             </a:r>
@@ -7238,9 +7238,9 @@
                 <a:solidFill>
                   <a:srgbClr val="FFFFFF"/>
                 </a:solidFill>
-                <a:latin typeface="KPMG-Bold" pitchFamily="34" charset="0"/>
-                <a:ea typeface="KPMG-Bold" pitchFamily="34" charset="-122"/>
-                <a:cs typeface="KPMG-Bold" pitchFamily="34" charset="-120"/>
+                <a:latin typeface="Arial" pitchFamily="34" charset="0"/>
+                <a:ea typeface="Arial" pitchFamily="34" charset="-122"/>
+                <a:cs typeface="Arial" pitchFamily="34" charset="-120"/>
               </a:rPr>
               <a:t>Unit Economics</a:t>
             </a:r>
@@ -7281,8 +7281,8 @@
         </p:nvSpPr>
         <p:spPr>
           <a:xfrm>
-            <a:off x="998433" y="431780"/>
-            <a:ext cx="10204338" cy="533370"/>
+            <a:off x="998400" y="431800"/>
+            <a:ext cx="10195200" cy="533400"/>
           </a:xfrm>
           <a:prstGeom prst="rect">
             <a:avLst/>
@@ -7298,17 +7298,17 @@
               <a:buNone/>
             </a:pPr>
             <a:r>
-              <a:rPr lang="en-US" sz="3200" b="1" dirty="0">
+              <a:rPr lang="en-US" sz="2400" b="1" dirty="0">
                 <a:solidFill>
                   <a:srgbClr val="00338D"/>
                 </a:solidFill>
-                <a:latin typeface="KPMG-Bold" pitchFamily="34" charset="0"/>
-                <a:ea typeface="KPMG-Bold" pitchFamily="34" charset="-122"/>
-                <a:cs typeface="KPMG-Bold" pitchFamily="34" charset="-120"/>
+                <a:latin typeface="Arial" pitchFamily="34" charset="0"/>
+                <a:ea typeface="Arial" pitchFamily="34" charset="-122"/>
+                <a:cs typeface="Arial" pitchFamily="34" charset="-120"/>
               </a:rPr>
               <a:t>Gross profit expanded with stable unit economics</a:t>
             </a:r>
-            <a:endParaRPr lang="en-US" sz="3200" dirty="0"/>
+            <a:endParaRPr lang="en-US" sz="2400" dirty="0"/>
           </a:p>
         </p:txBody>
       </p:sp>
@@ -7320,8 +7320,8 @@
         </p:nvSpPr>
         <p:spPr>
           <a:xfrm>
-            <a:off x="998433" y="1179485"/>
-            <a:ext cx="10204338" cy="482437"/>
+            <a:off x="995361" y="1179513"/>
+            <a:ext cx="10192299" cy="482400"/>
           </a:xfrm>
           <a:prstGeom prst="rect">
             <a:avLst/>
@@ -7359,8 +7359,8 @@
         </p:nvSpPr>
         <p:spPr>
           <a:xfrm>
-            <a:off x="998433" y="1716786"/>
-            <a:ext cx="5120640" cy="4459072"/>
+            <a:off x="995361" y="3859200"/>
+            <a:ext cx="5036400" cy="2016000"/>
           </a:xfrm>
           <a:prstGeom prst="rect">
             <a:avLst/>
@@ -7493,8 +7493,8 @@
           <p:nvPr/>
         </p:nvGraphicFramePr>
         <p:xfrm>
-          <a:off x="6400800" y="1716786"/>
-          <a:ext cx="4800600" cy="4184752"/>
+          <a:off x="6159600" y="3859199"/>
+          <a:ext cx="5036400" cy="2016000"/>
         </p:xfrm>
         <a:graphic xmlns:a="http://schemas.openxmlformats.org/drawingml/2006/main">
           <a:graphicData uri="http://schemas.openxmlformats.org/drawingml/2006/chart">
@@ -7510,8 +7510,8 @@
         </p:nvSpPr>
         <p:spPr>
           <a:xfrm>
-            <a:off x="6400800" y="5947258"/>
-            <a:ext cx="4800600" cy="182880"/>
+            <a:off x="6159600" y="5920919"/>
+            <a:ext cx="5036400" cy="182880"/>
           </a:xfrm>
           <a:prstGeom prst="rect">
             <a:avLst/>
@@ -7613,8 +7613,8 @@
         </p:nvSpPr>
         <p:spPr>
           <a:xfrm>
-            <a:off x="998433" y="431780"/>
-            <a:ext cx="10204338" cy="533370"/>
+            <a:off x="998400" y="431800"/>
+            <a:ext cx="10195200" cy="533400"/>
           </a:xfrm>
           <a:prstGeom prst="rect">
             <a:avLst/>
@@ -7630,17 +7630,17 @@
               <a:buNone/>
             </a:pPr>
             <a:r>
-              <a:rPr lang="en-US" sz="3200" b="1" dirty="0">
+              <a:rPr lang="en-US" sz="2400" b="1" dirty="0">
                 <a:solidFill>
                   <a:srgbClr val="00338D"/>
                 </a:solidFill>
-                <a:latin typeface="KPMG-Bold" pitchFamily="34" charset="0"/>
-                <a:ea typeface="KPMG-Bold" pitchFamily="34" charset="-122"/>
-                <a:cs typeface="KPMG-Bold" pitchFamily="34" charset="-120"/>
+                <a:latin typeface="Arial" pitchFamily="34" charset="0"/>
+                <a:ea typeface="Arial" pitchFamily="34" charset="-122"/>
+                <a:cs typeface="Arial" pitchFamily="34" charset="-120"/>
               </a:rPr>
               <a:t>Operating leverage is improving post-2024 dip</a:t>
             </a:r>
-            <a:endParaRPr lang="en-US" sz="3200" dirty="0"/>
+            <a:endParaRPr lang="en-US" sz="2400" dirty="0"/>
           </a:p>
         </p:txBody>
       </p:sp>
@@ -7652,8 +7652,8 @@
         </p:nvSpPr>
         <p:spPr>
           <a:xfrm>
-            <a:off x="998433" y="1179485"/>
-            <a:ext cx="10204338" cy="482437"/>
+            <a:off x="995361" y="1179513"/>
+            <a:ext cx="10192299" cy="482400"/>
           </a:xfrm>
           <a:prstGeom prst="rect">
             <a:avLst/>
@@ -7691,8 +7691,8 @@
         </p:nvSpPr>
         <p:spPr>
           <a:xfrm>
-            <a:off x="998433" y="1716786"/>
-            <a:ext cx="5120640" cy="4459072"/>
+            <a:off x="995361" y="3859200"/>
+            <a:ext cx="5036400" cy="2016000"/>
           </a:xfrm>
           <a:prstGeom prst="rect">
             <a:avLst/>
@@ -7825,8 +7825,8 @@
           <p:nvPr/>
         </p:nvGraphicFramePr>
         <p:xfrm>
-          <a:off x="6400800" y="1716786"/>
-          <a:ext cx="4800600" cy="4184752"/>
+          <a:off x="6159600" y="3859199"/>
+          <a:ext cx="5036400" cy="2016000"/>
         </p:xfrm>
         <a:graphic xmlns:a="http://schemas.openxmlformats.org/drawingml/2006/main">
           <a:graphicData uri="http://schemas.openxmlformats.org/drawingml/2006/chart">
@@ -7842,8 +7842,8 @@
         </p:nvSpPr>
         <p:spPr>
           <a:xfrm>
-            <a:off x="6400800" y="5947258"/>
-            <a:ext cx="4800600" cy="182880"/>
+            <a:off x="6159600" y="5920919"/>
+            <a:ext cx="5036400" cy="182880"/>
           </a:xfrm>
           <a:prstGeom prst="rect">
             <a:avLst/>
@@ -7962,17 +7962,17 @@
               <a:buNone/>
             </a:pPr>
             <a:r>
-              <a:rPr lang="en-US" sz="3200" b="1" dirty="0">
+              <a:rPr lang="en-US" sz="2400" b="1" dirty="0">
                 <a:solidFill>
                   <a:srgbClr val="00338D"/>
                 </a:solidFill>
-                <a:latin typeface="KPMG-Bold" pitchFamily="34" charset="0"/>
-                <a:ea typeface="KPMG-Bold" pitchFamily="34" charset="-122"/>
-                <a:cs typeface="KPMG-Bold" pitchFamily="34" charset="-120"/>
+                <a:latin typeface="Arial" pitchFamily="34" charset="0"/>
+                <a:ea typeface="Arial" pitchFamily="34" charset="-122"/>
+                <a:cs typeface="Arial" pitchFamily="34" charset="-120"/>
               </a:rPr>
               <a:t>Collections and NWC need tighter controls</a:t>
             </a:r>
-            <a:endParaRPr lang="en-US" sz="3200" dirty="0"/>
+            <a:endParaRPr lang="en-US" sz="2400" dirty="0"/>
           </a:p>
         </p:txBody>
       </p:sp>
@@ -9878,7 +9878,7 @@
             <a:r>
               <a:rPr lang="en-US" sz="600" i="1" dirty="0">
                 <a:solidFill>
-                  <a:srgbClr val="333333"/>
+                  <a:srgbClr val="0C233C"/>
                 </a:solidFill>
                 <a:latin typeface="Arial" pitchFamily="34" charset="0"/>
                 <a:ea typeface="Arial" pitchFamily="34" charset="-122"/>
@@ -9983,9 +9983,9 @@
                 <a:solidFill>
                   <a:srgbClr val="FFFFFF"/>
                 </a:solidFill>
-                <a:latin typeface="KPMG-Bold" pitchFamily="34" charset="0"/>
-                <a:ea typeface="KPMG-Bold" pitchFamily="34" charset="-122"/>
-                <a:cs typeface="KPMG-Bold" pitchFamily="34" charset="-120"/>
+                <a:latin typeface="Arial" pitchFamily="34" charset="0"/>
+                <a:ea typeface="Arial" pitchFamily="34" charset="-122"/>
+                <a:cs typeface="Arial" pitchFamily="34" charset="-120"/>
               </a:rPr>
               <a:t>05</a:t>
             </a:r>
@@ -10022,9 +10022,9 @@
                 <a:solidFill>
                   <a:srgbClr val="FFFFFF"/>
                 </a:solidFill>
-                <a:latin typeface="KPMG-Bold" pitchFamily="34" charset="0"/>
-                <a:ea typeface="KPMG-Bold" pitchFamily="34" charset="-122"/>
-                <a:cs typeface="KPMG-Bold" pitchFamily="34" charset="-120"/>
+                <a:latin typeface="Arial" pitchFamily="34" charset="0"/>
+                <a:ea typeface="Arial" pitchFamily="34" charset="-122"/>
+                <a:cs typeface="Arial" pitchFamily="34" charset="-120"/>
               </a:rPr>
               <a:t>Risks and Recommendations</a:t>
             </a:r>
@@ -10082,17 +10082,17 @@
               <a:buNone/>
             </a:pPr>
             <a:r>
-              <a:rPr lang="en-US" sz="3200" b="1" dirty="0">
+              <a:rPr lang="en-US" sz="2400" b="1" dirty="0">
                 <a:solidFill>
                   <a:srgbClr val="00338D"/>
                 </a:solidFill>
-                <a:latin typeface="KPMG-Bold" pitchFamily="34" charset="0"/>
-                <a:ea typeface="KPMG-Bold" pitchFamily="34" charset="-122"/>
-                <a:cs typeface="KPMG-Bold" pitchFamily="34" charset="-120"/>
+                <a:latin typeface="Arial" pitchFamily="34" charset="0"/>
+                <a:ea typeface="Arial" pitchFamily="34" charset="-122"/>
+                <a:cs typeface="Arial" pitchFamily="34" charset="-120"/>
               </a:rPr>
               <a:t>Primary risks are identifiable and actionable</a:t>
             </a:r>
-            <a:endParaRPr lang="en-US" sz="3200" dirty="0"/>
+            <a:endParaRPr lang="en-US" sz="2400" dirty="0"/>
           </a:p>
         </p:txBody>
       </p:sp>
@@ -10537,8 +10537,8 @@
         </p:nvSpPr>
         <p:spPr>
           <a:xfrm>
-            <a:off x="998433" y="431780"/>
-            <a:ext cx="10204338" cy="533370"/>
+            <a:off x="998400" y="431800"/>
+            <a:ext cx="10195200" cy="533400"/>
           </a:xfrm>
           <a:prstGeom prst="rect">
             <a:avLst/>
@@ -10554,17 +10554,17 @@
               <a:buNone/>
             </a:pPr>
             <a:r>
-              <a:rPr lang="en-US" sz="3200" b="1" dirty="0">
+              <a:rPr lang="en-US" sz="2400" b="1" dirty="0">
                 <a:solidFill>
                   <a:srgbClr val="00338D"/>
                 </a:solidFill>
-                <a:latin typeface="KPMG-Bold" pitchFamily="34" charset="0"/>
-                <a:ea typeface="KPMG-Bold" pitchFamily="34" charset="-122"/>
-                <a:cs typeface="KPMG-Bold" pitchFamily="34" charset="-120"/>
+                <a:latin typeface="Arial" pitchFamily="34" charset="0"/>
+                <a:ea typeface="Arial" pitchFamily="34" charset="-122"/>
+                <a:cs typeface="Arial" pitchFamily="34" charset="-120"/>
               </a:rPr>
               <a:t>Next steps for diligence-to-value creation handoff</a:t>
             </a:r>
-            <a:endParaRPr lang="en-US" sz="3200" dirty="0"/>
+            <a:endParaRPr lang="en-US" sz="2400" dirty="0"/>
           </a:p>
         </p:txBody>
       </p:sp>
@@ -10615,8 +10615,8 @@
         </p:nvSpPr>
         <p:spPr>
           <a:xfrm>
-            <a:off x="998433" y="1716786"/>
-            <a:ext cx="10204338" cy="4248760"/>
+            <a:off x="997200" y="1716786"/>
+            <a:ext cx="10195200" cy="4157127"/>
           </a:xfrm>
           <a:prstGeom prst="rect">
             <a:avLst/>
@@ -10821,8 +10821,8 @@
         </p:nvSpPr>
         <p:spPr>
           <a:xfrm>
-            <a:off x="998433" y="5992978"/>
-            <a:ext cx="10204338" cy="182880"/>
+            <a:off x="997200" y="5992978"/>
+            <a:ext cx="10195200" cy="182880"/>
           </a:xfrm>
           <a:prstGeom prst="rect">
             <a:avLst/>
@@ -10941,17 +10941,17 @@
               <a:buNone/>
             </a:pPr>
             <a:r>
-              <a:rPr lang="en-US" sz="3200" b="1" dirty="0">
+              <a:rPr lang="en-US" sz="2400" b="1" dirty="0">
                 <a:solidFill>
                   <a:srgbClr val="00338D"/>
                 </a:solidFill>
-                <a:latin typeface="KPMG-Bold" pitchFamily="34" charset="0"/>
-                <a:ea typeface="KPMG-Bold" pitchFamily="34" charset="-122"/>
-                <a:cs typeface="KPMG-Bold" pitchFamily="34" charset="-120"/>
+                <a:latin typeface="Arial" pitchFamily="34" charset="0"/>
+                <a:ea typeface="Arial" pitchFamily="34" charset="-122"/>
+                <a:cs typeface="Arial" pitchFamily="34" charset="-120"/>
               </a:rPr>
               <a:t>Contents</a:t>
             </a:r>
-            <a:endParaRPr lang="en-US" sz="3200" dirty="0"/>
+            <a:endParaRPr lang="en-US" sz="2400" dirty="0"/>
           </a:p>
         </p:txBody>
       </p:sp>
@@ -10984,9 +10984,9 @@
                 <a:solidFill>
                   <a:srgbClr val="00338D"/>
                 </a:solidFill>
-                <a:latin typeface="KPMG-Bold" pitchFamily="34" charset="0"/>
-                <a:ea typeface="KPMG-Bold" pitchFamily="34" charset="-122"/>
-                <a:cs typeface="KPMG-Bold" pitchFamily="34" charset="-120"/>
+                <a:latin typeface="Arial" pitchFamily="34" charset="0"/>
+                <a:ea typeface="Arial" pitchFamily="34" charset="-122"/>
+                <a:cs typeface="Arial" pitchFamily="34" charset="-120"/>
               </a:rPr>
               <a:t>01</a:t>
             </a:r>
@@ -11180,9 +11180,9 @@
                 <a:solidFill>
                   <a:srgbClr val="00338D"/>
                 </a:solidFill>
-                <a:latin typeface="KPMG-Bold" pitchFamily="34" charset="0"/>
-                <a:ea typeface="KPMG-Bold" pitchFamily="34" charset="-122"/>
-                <a:cs typeface="KPMG-Bold" pitchFamily="34" charset="-120"/>
+                <a:latin typeface="Arial" pitchFamily="34" charset="0"/>
+                <a:ea typeface="Arial" pitchFamily="34" charset="-122"/>
+                <a:cs typeface="Arial" pitchFamily="34" charset="-120"/>
               </a:rPr>
               <a:t>02</a:t>
             </a:r>
@@ -11376,9 +11376,9 @@
                 <a:solidFill>
                   <a:srgbClr val="00338D"/>
                 </a:solidFill>
-                <a:latin typeface="KPMG-Bold" pitchFamily="34" charset="0"/>
-                <a:ea typeface="KPMG-Bold" pitchFamily="34" charset="-122"/>
-                <a:cs typeface="KPMG-Bold" pitchFamily="34" charset="-120"/>
+                <a:latin typeface="Arial" pitchFamily="34" charset="0"/>
+                <a:ea typeface="Arial" pitchFamily="34" charset="-122"/>
+                <a:cs typeface="Arial" pitchFamily="34" charset="-120"/>
               </a:rPr>
               <a:t>03</a:t>
             </a:r>
@@ -11572,9 +11572,9 @@
                 <a:solidFill>
                   <a:srgbClr val="00338D"/>
                 </a:solidFill>
-                <a:latin typeface="KPMG-Bold" pitchFamily="34" charset="0"/>
-                <a:ea typeface="KPMG-Bold" pitchFamily="34" charset="-122"/>
-                <a:cs typeface="KPMG-Bold" pitchFamily="34" charset="-120"/>
+                <a:latin typeface="Arial" pitchFamily="34" charset="0"/>
+                <a:ea typeface="Arial" pitchFamily="34" charset="-122"/>
+                <a:cs typeface="Arial" pitchFamily="34" charset="-120"/>
               </a:rPr>
               <a:t>04</a:t>
             </a:r>
@@ -11768,9 +11768,9 @@
                 <a:solidFill>
                   <a:srgbClr val="00338D"/>
                 </a:solidFill>
-                <a:latin typeface="KPMG-Bold" pitchFamily="34" charset="0"/>
-                <a:ea typeface="KPMG-Bold" pitchFamily="34" charset="-122"/>
-                <a:cs typeface="KPMG-Bold" pitchFamily="34" charset="-120"/>
+                <a:latin typeface="Arial" pitchFamily="34" charset="0"/>
+                <a:ea typeface="Arial" pitchFamily="34" charset="-122"/>
+                <a:cs typeface="Arial" pitchFamily="34" charset="-120"/>
               </a:rPr>
               <a:t>05</a:t>
             </a:r>
@@ -12052,9 +12052,9 @@
                 <a:solidFill>
                   <a:srgbClr val="FFFFFF"/>
                 </a:solidFill>
-                <a:latin typeface="KPMG-Bold" pitchFamily="34" charset="0"/>
-                <a:ea typeface="KPMG-Bold" pitchFamily="34" charset="-122"/>
-                <a:cs typeface="KPMG-Bold" pitchFamily="34" charset="-120"/>
+                <a:latin typeface="Arial" pitchFamily="34" charset="0"/>
+                <a:ea typeface="Arial" pitchFamily="34" charset="-122"/>
+                <a:cs typeface="Arial" pitchFamily="34" charset="-120"/>
               </a:rPr>
               <a:t>The contacts at KPMG in connection with this report are:</a:t>
             </a:r>
@@ -12737,9 +12737,9 @@
                 <a:solidFill>
                   <a:srgbClr val="FFFFFF"/>
                 </a:solidFill>
-                <a:latin typeface="KPMG-Bold" pitchFamily="34" charset="0"/>
-                <a:ea typeface="KPMG-Bold" pitchFamily="34" charset="-122"/>
-                <a:cs typeface="KPMG-Bold" pitchFamily="34" charset="-120"/>
+                <a:latin typeface="Arial" pitchFamily="34" charset="0"/>
+                <a:ea typeface="Arial" pitchFamily="34" charset="-122"/>
+                <a:cs typeface="Arial" pitchFamily="34" charset="-120"/>
               </a:rPr>
               <a:t>01</a:t>
             </a:r>
@@ -12776,9 +12776,9 @@
                 <a:solidFill>
                   <a:srgbClr val="FFFFFF"/>
                 </a:solidFill>
-                <a:latin typeface="KPMG-Bold" pitchFamily="34" charset="0"/>
-                <a:ea typeface="KPMG-Bold" pitchFamily="34" charset="-122"/>
-                <a:cs typeface="KPMG-Bold" pitchFamily="34" charset="-120"/>
+                <a:latin typeface="Arial" pitchFamily="34" charset="0"/>
+                <a:ea typeface="Arial" pitchFamily="34" charset="-122"/>
+                <a:cs typeface="Arial" pitchFamily="34" charset="-120"/>
               </a:rPr>
               <a:t>Executive Summary</a:t>
             </a:r>
@@ -12819,8 +12819,8 @@
         </p:nvSpPr>
         <p:spPr>
           <a:xfrm>
-            <a:off x="998433" y="431780"/>
-            <a:ext cx="10204338" cy="533370"/>
+            <a:off x="998400" y="431800"/>
+            <a:ext cx="10195200" cy="533400"/>
           </a:xfrm>
           <a:prstGeom prst="rect">
             <a:avLst/>
@@ -12836,17 +12836,17 @@
               <a:buNone/>
             </a:pPr>
             <a:r>
-              <a:rPr lang="en-US" sz="3200" b="1" dirty="0">
+              <a:rPr lang="en-US" sz="2400" b="1" dirty="0">
                 <a:solidFill>
                   <a:srgbClr val="00338D"/>
                 </a:solidFill>
-                <a:latin typeface="KPMG-Bold" pitchFamily="34" charset="0"/>
-                <a:ea typeface="KPMG-Bold" pitchFamily="34" charset="-122"/>
-                <a:cs typeface="KPMG-Bold" pitchFamily="34" charset="-120"/>
+                <a:latin typeface="Arial" pitchFamily="34" charset="0"/>
+                <a:ea typeface="Arial" pitchFamily="34" charset="-122"/>
+                <a:cs typeface="Arial" pitchFamily="34" charset="-120"/>
               </a:rPr>
               <a:t>Revenue scaled 27.5% CAGR with margin resilience</a:t>
             </a:r>
-            <a:endParaRPr lang="en-US" sz="3200" dirty="0"/>
+            <a:endParaRPr lang="en-US" sz="2400" dirty="0"/>
           </a:p>
         </p:txBody>
       </p:sp>
@@ -12858,8 +12858,8 @@
         </p:nvSpPr>
         <p:spPr>
           <a:xfrm>
-            <a:off x="998433" y="1179485"/>
-            <a:ext cx="10204338" cy="482437"/>
+            <a:off x="995361" y="1179513"/>
+            <a:ext cx="10192299" cy="482400"/>
           </a:xfrm>
           <a:prstGeom prst="rect">
             <a:avLst/>
@@ -12897,8 +12897,8 @@
         </p:nvSpPr>
         <p:spPr>
           <a:xfrm>
-            <a:off x="998433" y="1716786"/>
-            <a:ext cx="5120640" cy="4459072"/>
+            <a:off x="995361" y="3859200"/>
+            <a:ext cx="5036400" cy="2016000"/>
           </a:xfrm>
           <a:prstGeom prst="rect">
             <a:avLst/>
@@ -13031,8 +13031,8 @@
           <p:nvPr/>
         </p:nvGraphicFramePr>
         <p:xfrm>
-          <a:off x="6400800" y="1716786"/>
-          <a:ext cx="4800600" cy="4184752"/>
+          <a:off x="6159600" y="3859199"/>
+          <a:ext cx="5036400" cy="2016000"/>
         </p:xfrm>
         <a:graphic xmlns:a="http://schemas.openxmlformats.org/drawingml/2006/main">
           <a:graphicData uri="http://schemas.openxmlformats.org/drawingml/2006/chart">
@@ -13048,8 +13048,8 @@
         </p:nvSpPr>
         <p:spPr>
           <a:xfrm>
-            <a:off x="6400800" y="5947258"/>
-            <a:ext cx="4800600" cy="182880"/>
+            <a:off x="6159600" y="5920919"/>
+            <a:ext cx="5036400" cy="182880"/>
           </a:xfrm>
           <a:prstGeom prst="rect">
             <a:avLst/>
@@ -13168,17 +13168,17 @@
               <a:buNone/>
             </a:pPr>
             <a:r>
-              <a:rPr lang="en-US" sz="3200" b="1" dirty="0">
+              <a:rPr lang="en-US" sz="2400" b="1" dirty="0">
                 <a:solidFill>
                   <a:srgbClr val="00338D"/>
                 </a:solidFill>
-                <a:latin typeface="KPMG-Bold" pitchFamily="34" charset="0"/>
-                <a:ea typeface="KPMG-Bold" pitchFamily="34" charset="-122"/>
-                <a:cs typeface="KPMG-Bold" pitchFamily="34" charset="-120"/>
+                <a:latin typeface="Arial" pitchFamily="34" charset="0"/>
+                <a:ea typeface="Arial" pitchFamily="34" charset="-122"/>
+                <a:cs typeface="Arial" pitchFamily="34" charset="-120"/>
               </a:rPr>
               <a:t>Investment case is attractive with clear watchouts</a:t>
             </a:r>
-            <a:endParaRPr lang="en-US" sz="3200" dirty="0"/>
+            <a:endParaRPr lang="en-US" sz="2400" dirty="0"/>
           </a:p>
         </p:txBody>
       </p:sp>
@@ -14852,7 +14852,7 @@
             <a:r>
               <a:rPr lang="en-US" sz="600" i="1" dirty="0">
                 <a:solidFill>
-                  <a:srgbClr val="333333"/>
+                  <a:srgbClr val="0C233C"/>
                 </a:solidFill>
                 <a:latin typeface="Arial" pitchFamily="34" charset="0"/>
                 <a:ea typeface="Arial" pitchFamily="34" charset="-122"/>
@@ -14957,9 +14957,9 @@
                 <a:solidFill>
                   <a:srgbClr val="FFFFFF"/>
                 </a:solidFill>
-                <a:latin typeface="KPMG-Bold" pitchFamily="34" charset="0"/>
-                <a:ea typeface="KPMG-Bold" pitchFamily="34" charset="-122"/>
-                <a:cs typeface="KPMG-Bold" pitchFamily="34" charset="-120"/>
+                <a:latin typeface="Arial" pitchFamily="34" charset="0"/>
+                <a:ea typeface="Arial" pitchFamily="34" charset="-122"/>
+                <a:cs typeface="Arial" pitchFamily="34" charset="-120"/>
               </a:rPr>
               <a:t>02</a:t>
             </a:r>
@@ -14996,9 +14996,9 @@
                 <a:solidFill>
                   <a:srgbClr val="FFFFFF"/>
                 </a:solidFill>
-                <a:latin typeface="KPMG-Bold" pitchFamily="34" charset="0"/>
-                <a:ea typeface="KPMG-Bold" pitchFamily="34" charset="-122"/>
-                <a:cs typeface="KPMG-Bold" pitchFamily="34" charset="-120"/>
+                <a:latin typeface="Arial" pitchFamily="34" charset="0"/>
+                <a:ea typeface="Arial" pitchFamily="34" charset="-122"/>
+                <a:cs typeface="Arial" pitchFamily="34" charset="-120"/>
               </a:rPr>
               <a:t>Market and Product</a:t>
             </a:r>
@@ -15039,8 +15039,8 @@
         </p:nvSpPr>
         <p:spPr>
           <a:xfrm>
-            <a:off x="998433" y="431780"/>
-            <a:ext cx="10204338" cy="533370"/>
+            <a:off x="998400" y="431800"/>
+            <a:ext cx="10195200" cy="533400"/>
           </a:xfrm>
           <a:prstGeom prst="rect">
             <a:avLst/>
@@ -15056,17 +15056,17 @@
               <a:buNone/>
             </a:pPr>
             <a:r>
-              <a:rPr lang="en-US" sz="3200" b="1" dirty="0">
+              <a:rPr lang="en-US" sz="2400" b="1" dirty="0">
                 <a:solidFill>
                   <a:srgbClr val="00338D"/>
                 </a:solidFill>
-                <a:latin typeface="KPMG-Bold" pitchFamily="34" charset="0"/>
-                <a:ea typeface="KPMG-Bold" pitchFamily="34" charset="-122"/>
-                <a:cs typeface="KPMG-Bold" pitchFamily="34" charset="-120"/>
+                <a:latin typeface="Arial" pitchFamily="34" charset="0"/>
+                <a:ea typeface="Arial" pitchFamily="34" charset="-122"/>
+                <a:cs typeface="Arial" pitchFamily="34" charset="-120"/>
               </a:rPr>
               <a:t>EdTech positioning supports continued expansion</a:t>
             </a:r>
-            <a:endParaRPr lang="en-US" sz="3200" dirty="0"/>
+            <a:endParaRPr lang="en-US" sz="2400" dirty="0"/>
           </a:p>
         </p:txBody>
       </p:sp>
@@ -15117,8 +15117,8 @@
         </p:nvSpPr>
         <p:spPr>
           <a:xfrm>
-            <a:off x="998433" y="1716786"/>
-            <a:ext cx="10204338" cy="4248760"/>
+            <a:off x="997200" y="1716786"/>
+            <a:ext cx="10195200" cy="4157127"/>
           </a:xfrm>
           <a:prstGeom prst="rect">
             <a:avLst/>
@@ -15319,8 +15319,8 @@
         </p:nvSpPr>
         <p:spPr>
           <a:xfrm>
-            <a:off x="998433" y="5992978"/>
-            <a:ext cx="10204338" cy="182880"/>
+            <a:off x="997200" y="5992978"/>
+            <a:ext cx="10195200" cy="182880"/>
           </a:xfrm>
           <a:prstGeom prst="rect">
             <a:avLst/>
@@ -15422,8 +15422,8 @@
         </p:nvSpPr>
         <p:spPr>
           <a:xfrm>
-            <a:off x="998433" y="431780"/>
-            <a:ext cx="10204338" cy="533370"/>
+            <a:off x="998400" y="431800"/>
+            <a:ext cx="10195200" cy="533400"/>
           </a:xfrm>
           <a:prstGeom prst="rect">
             <a:avLst/>
@@ -15439,17 +15439,17 @@
               <a:buNone/>
             </a:pPr>
             <a:r>
-              <a:rPr lang="en-US" sz="3200" b="1" dirty="0">
+              <a:rPr lang="en-US" sz="2400" b="1" dirty="0">
                 <a:solidFill>
                   <a:srgbClr val="00338D"/>
                 </a:solidFill>
-                <a:latin typeface="KPMG-Bold" pitchFamily="34" charset="0"/>
-                <a:ea typeface="KPMG-Bold" pitchFamily="34" charset="-122"/>
-                <a:cs typeface="KPMG-Bold" pitchFamily="34" charset="-120"/>
+                <a:latin typeface="Arial" pitchFamily="34" charset="0"/>
+                <a:ea typeface="Arial" pitchFamily="34" charset="-122"/>
+                <a:cs typeface="Arial" pitchFamily="34" charset="-120"/>
               </a:rPr>
               <a:t>Three-tier packaging supports land-and-expand</a:t>
             </a:r>
-            <a:endParaRPr lang="en-US" sz="3200" dirty="0"/>
+            <a:endParaRPr lang="en-US" sz="2400" dirty="0"/>
           </a:p>
         </p:txBody>
       </p:sp>
@@ -16781,9 +16781,9 @@
                 <a:solidFill>
                   <a:srgbClr val="FFFFFF"/>
                 </a:solidFill>
-                <a:latin typeface="KPMG-Bold" pitchFamily="34" charset="0"/>
-                <a:ea typeface="KPMG-Bold" pitchFamily="34" charset="-122"/>
-                <a:cs typeface="KPMG-Bold" pitchFamily="34" charset="-120"/>
+                <a:latin typeface="Arial" pitchFamily="34" charset="0"/>
+                <a:ea typeface="Arial" pitchFamily="34" charset="-122"/>
+                <a:cs typeface="Arial" pitchFamily="34" charset="-120"/>
               </a:rPr>
               <a:t>03</a:t>
             </a:r>
@@ -16820,9 +16820,9 @@
                 <a:solidFill>
                   <a:srgbClr val="FFFFFF"/>
                 </a:solidFill>
-                <a:latin typeface="KPMG-Bold" pitchFamily="34" charset="0"/>
-                <a:ea typeface="KPMG-Bold" pitchFamily="34" charset="-122"/>
-                <a:cs typeface="KPMG-Bold" pitchFamily="34" charset="-120"/>
+                <a:latin typeface="Arial" pitchFamily="34" charset="0"/>
+                <a:ea typeface="Arial" pitchFamily="34" charset="-122"/>
+                <a:cs typeface="Arial" pitchFamily="34" charset="-120"/>
               </a:rPr>
               <a:t>Growth Quality</a:t>
             </a:r>

</xml_diff>